<commit_message>
Working peak alignment algorithm
</commit_message>
<xml_diff>
--- a/presentations/Presentation for 1.17.25.pptx
+++ b/presentations/Presentation for 1.17.25.pptx
@@ -11,6 +11,7 @@
     <p:sldId id="258" r:id="rId5"/>
     <p:sldId id="259" r:id="rId6"/>
     <p:sldId id="260" r:id="rId7"/>
+    <p:sldId id="262" r:id="rId8"/>
   </p:sldIdLst>
   <p:sldSz cx="12192000" cy="6858000"/>
   <p:notesSz cx="6858000" cy="9144000"/>
@@ -109,6 +110,11 @@
       </a:defRPr>
     </a:lvl9pPr>
   </p:defaultTextStyle>
+  <p:extLst>
+    <p:ext uri="{EFAFB233-063F-42B5-8137-9DF3F51BA10A}">
+      <p15:sldGuideLst xmlns:p15="http://schemas.microsoft.com/office/powerpoint/2012/main"/>
+    </p:ext>
+  </p:extLst>
 </p:presentation>
 </file>
 
@@ -6441,6 +6447,140 @@
     <p:extLst>
       <p:ext uri="{BB962C8B-B14F-4D97-AF65-F5344CB8AC3E}">
         <p14:creationId xmlns:p14="http://schemas.microsoft.com/office/powerpoint/2010/main" val="482864849"/>
+      </p:ext>
+    </p:extLst>
+  </p:cSld>
+  <p:clrMapOvr>
+    <a:masterClrMapping/>
+  </p:clrMapOvr>
+</p:sld>
+</file>
+
+<file path=ppt/slides/slide7.xml><?xml version="1.0" encoding="utf-8"?>
+<p:sld xmlns:a="http://schemas.openxmlformats.org/drawingml/2006/main" xmlns:r="http://schemas.openxmlformats.org/officeDocument/2006/relationships" xmlns:p="http://schemas.openxmlformats.org/presentationml/2006/main">
+  <p:cSld>
+    <p:spTree>
+      <p:nvGrpSpPr>
+        <p:cNvPr id="1" name=""/>
+        <p:cNvGrpSpPr/>
+        <p:nvPr/>
+      </p:nvGrpSpPr>
+      <p:grpSpPr>
+        <a:xfrm>
+          <a:off x="0" y="0"/>
+          <a:ext cx="0" cy="0"/>
+          <a:chOff x="0" y="0"/>
+          <a:chExt cx="0" cy="0"/>
+        </a:xfrm>
+      </p:grpSpPr>
+      <p:sp>
+        <p:nvSpPr>
+          <p:cNvPr id="2" name="Title 1">
+            <a:extLst>
+              <a:ext uri="{FF2B5EF4-FFF2-40B4-BE49-F238E27FC236}">
+                <a16:creationId xmlns:a16="http://schemas.microsoft.com/office/drawing/2014/main" id="{8E93233D-4C26-3574-DABF-9C30D633A639}"/>
+              </a:ext>
+            </a:extLst>
+          </p:cNvPr>
+          <p:cNvSpPr>
+            <a:spLocks noGrp="1"/>
+          </p:cNvSpPr>
+          <p:nvPr>
+            <p:ph type="title"/>
+          </p:nvPr>
+        </p:nvSpPr>
+        <p:spPr/>
+        <p:txBody>
+          <a:bodyPr/>
+          <a:lstStyle/>
+          <a:p>
+            <a:r>
+              <a:rPr lang="en-US" dirty="0"/>
+              <a:t>Operating with experimental data</a:t>
+            </a:r>
+          </a:p>
+        </p:txBody>
+      </p:sp>
+      <p:pic>
+        <p:nvPicPr>
+          <p:cNvPr id="7" name="Picture 6" descr="A screen shot of a computer screen&#10;&#10;Description automatically generated">
+            <a:extLst>
+              <a:ext uri="{FF2B5EF4-FFF2-40B4-BE49-F238E27FC236}">
+                <a16:creationId xmlns:a16="http://schemas.microsoft.com/office/drawing/2014/main" id="{B37F5BEE-C37A-0A5C-8049-6480B3B87E23}"/>
+              </a:ext>
+            </a:extLst>
+          </p:cNvPr>
+          <p:cNvPicPr>
+            <a:picLocks noChangeAspect="1"/>
+          </p:cNvPicPr>
+          <p:nvPr/>
+        </p:nvPicPr>
+        <p:blipFill>
+          <a:blip r:embed="rId2">
+            <a:extLst>
+              <a:ext uri="{28A0092B-C50C-407E-A947-70E740481C1C}">
+                <a14:useLocalDpi xmlns:a14="http://schemas.microsoft.com/office/drawing/2010/main" val="0"/>
+              </a:ext>
+            </a:extLst>
+          </a:blip>
+          <a:srcRect l="32657" t="30946" r="37578" b="18136"/>
+          <a:stretch/>
+        </p:blipFill>
+        <p:spPr>
+          <a:xfrm>
+            <a:off x="180975" y="2009775"/>
+            <a:ext cx="3629025" cy="3028950"/>
+          </a:xfrm>
+          <a:prstGeom prst="rect">
+            <a:avLst/>
+          </a:prstGeom>
+        </p:spPr>
+      </p:pic>
+      <p:sp>
+        <p:nvSpPr>
+          <p:cNvPr id="8" name="TextBox 7">
+            <a:extLst>
+              <a:ext uri="{FF2B5EF4-FFF2-40B4-BE49-F238E27FC236}">
+                <a16:creationId xmlns:a16="http://schemas.microsoft.com/office/drawing/2014/main" id="{682729F2-2927-AC4C-E026-9769D78B6838}"/>
+              </a:ext>
+            </a:extLst>
+          </p:cNvPr>
+          <p:cNvSpPr txBox="1"/>
+          <p:nvPr/>
+        </p:nvSpPr>
+        <p:spPr>
+          <a:xfrm>
+            <a:off x="3810000" y="2438400"/>
+            <a:ext cx="7334250" cy="1200329"/>
+          </a:xfrm>
+          <a:prstGeom prst="rect">
+            <a:avLst/>
+          </a:prstGeom>
+          <a:noFill/>
+        </p:spPr>
+        <p:txBody>
+          <a:bodyPr wrap="square" rtlCol="0">
+            <a:spAutoFit/>
+          </a:bodyPr>
+          <a:lstStyle/>
+          <a:p>
+            <a:r>
+              <a:rPr lang="en-US" dirty="0"/>
+              <a:t>Visualizing clusters – processes files in a comparable time to Agilent’s mass profiler despite being more advanced</a:t>
+            </a:r>
+          </a:p>
+          <a:p>
+            <a:r>
+              <a:rPr lang="en-US" dirty="0"/>
+              <a:t>Processing &gt;30000 rows of data from 4 experimental files to produce &gt;8000 clusters in 20 seconds</a:t>
+            </a:r>
+          </a:p>
+        </p:txBody>
+      </p:sp>
+    </p:spTree>
+    <p:extLst>
+      <p:ext uri="{BB962C8B-B14F-4D97-AF65-F5344CB8AC3E}">
+        <p14:creationId xmlns:p14="http://schemas.microsoft.com/office/powerpoint/2010/main" val="2152588614"/>
       </p:ext>
     </p:extLst>
   </p:cSld>

</xml_diff>